<commit_message>
Mark Nota 02 as completed with Finance memo 04_2026 evidence
Co-Authored-By: Claude Opus 5.5 <noreply@anthropic.com>
Claude-Session: https://claude.ai/code/session_012D3KgoL7WmAgwT84y3f3Gg
</commit_message>
<xml_diff>
--- a/seguimiento-comite-riesgos-sesion-150/Seguimiento_Acuerdos_Comite_Riesgo_Sesion_150.pptx
+++ b/seguimiento-comite-riesgos-sesion-150/Seguimiento_Acuerdos_Comite_Riesgo_Sesion_150.pptx
@@ -2592,7 +2592,7 @@
                   <a:schemeClr val="tx2"/>
                 </a:solidFill>
               </a:rPr>
-              <a:t>4 acuerdos en seguimiento: 2 atendidos y 2 en proceso</a:t>
+              <a:t>4 acuerdos en seguimiento: 3 atendidos y 1 en proceso</a:t>
             </a:r>
             <a:endParaRPr lang="en-US" sz="3400" dirty="0"/>
           </a:p>
@@ -2744,7 +2744,7 @@
                   <a:schemeClr val="accent2"/>
                 </a:solidFill>
               </a:rPr>
-              <a:t>2</a:t>
+              <a:t>3</a:t>
             </a:r>
             <a:endParaRPr lang="en-US" sz="6000" dirty="0"/>
           </a:p>
@@ -2838,7 +2838,7 @@
                   <a:schemeClr val="accent3"/>
                 </a:solidFill>
               </a:rPr>
-              <a:t>2</a:t>
+              <a:t>1</a:t>
             </a:r>
             <a:endParaRPr lang="en-US" sz="6000" dirty="0"/>
           </a:p>
@@ -2874,7 +2874,7 @@
                   <a:schemeClr val="tx1"/>
                 </a:solidFill>
               </a:rPr>
-              <a:t>Análisis pendientes de presentar</a:t>
+              <a:t>Análisis pendiente de presentar</a:t>
             </a:r>
             <a:endParaRPr lang="en-US" sz="1500" dirty="0"/>
           </a:p>
@@ -3298,7 +3298,7 @@
       </p:sp>
       <p:sp>
         <p:nvSpPr>
-          <p:cNvPr id="26" name="Estado EN PROCESO"/>
+          <p:cNvPr id="26" name="Estado CUMPLIDO"/>
           <p:cNvSpPr txBox="1"/>
           <p:nvPr/>
         </p:nvSpPr>
@@ -3313,7 +3313,7 @@
             </a:avLst>
           </a:prstGeom>
           <a:solidFill>
-            <a:schemeClr val="accent3"/>
+            <a:schemeClr val="accent2"/>
           </a:solidFill>
           <a:ln/>
         </p:spPr>
@@ -3330,7 +3330,7 @@
                   <a:schemeClr val="bg1"/>
                 </a:solidFill>
               </a:rPr>
-              <a:t>EN PROCESO</a:t>
+              <a:t>CUMPLIDO</a:t>
             </a:r>
             <a:endParaRPr lang="en-US" sz="1200" dirty="0"/>
           </a:p>
@@ -4807,7 +4807,7 @@
                             <a:schemeClr val="tx1"/>
                           </a:solidFill>
                         </a:rPr>
-                        <a:t>Nota recibida el 10/09/2026. Análisis pendiente de presentación</a:t>
+                        <a:t>Memorando 04_2026 (30/09/2026): liberación $1,073,528.39 (4.33% de ingresos); recuperación castigada $121,441.73 (0.49%)</a:t>
                       </a:r>
                       <a:endParaRPr lang="en-US" sz="1200" dirty="0"/>
                     </a:p>
@@ -4868,7 +4868,7 @@
                             <a:schemeClr val="bg1"/>
                           </a:solidFill>
                         </a:rPr>
-                        <a:t>EN PROCESO</a:t>
+                        <a:t>CUMPLIDO</a:t>
                       </a:r>
                       <a:endParaRPr lang="en-US" sz="1100" dirty="0"/>
                     </a:p>
@@ -4911,7 +4911,7 @@
                       <a:tailEnd type="none" w="med" len="med"/>
                     </a:lnB>
                     <a:solidFill>
-                      <a:schemeClr val="accent3"/>
+                      <a:schemeClr val="accent2"/>
                     </a:solidFill>
                   </a:tcPr>
                 </a:tc>
@@ -7092,7 +7092,7 @@
             </a:avLst>
           </a:prstGeom>
           <a:solidFill>
-            <a:schemeClr val="accent3"/>
+            <a:schemeClr val="accent2"/>
           </a:solidFill>
           <a:ln/>
         </p:spPr>
@@ -7165,7 +7165,7 @@
                   <a:schemeClr val="bg1"/>
                 </a:solidFill>
               </a:rPr>
-              <a:t>EN PROCESO</a:t>
+              <a:t>CUMPLIDO</a:t>
             </a:r>
             <a:endParaRPr lang="en-US" sz="1400" dirty="0"/>
           </a:p>
@@ -7232,7 +7232,7 @@
                   <a:schemeClr val="accent1"/>
                 </a:solidFill>
               </a:rPr>
-              <a:t>NOTA DEL COMITÉ</a:t>
+              <a:t>MEMORANDO 04_2026</a:t>
             </a:r>
             <a:endParaRPr lang="en-US" sz="1100" dirty="0"/>
           </a:p>
@@ -7268,7 +7268,7 @@
                   <a:schemeClr val="accent5"/>
                 </a:solidFill>
               </a:rPr>
-              <a:t>Acuerdo CR-2026-49, literal j) · Recibida el 10/09/2026</a:t>
+              <a:t>30/09/2026 · Recibido por el Consejo de Administración el 01/10/2026</a:t>
             </a:r>
             <a:endParaRPr lang="en-US" sz="1200" dirty="0"/>
           </a:p>
@@ -7593,80 +7593,26 @@
       </p:sp>
       <p:sp>
         <p:nvSpPr>
-          <p:cNvPr id="25" name="Text 18"/>
-          <p:cNvSpPr txBox="1"/>
+          <p:cNvPr id="25" name="Cifra Liberación de reservas"/>
+          <p:cNvSpPr/>
           <p:nvPr/>
         </p:nvSpPr>
         <p:spPr>
           <a:xfrm>
             <a:off x="4480560" y="4434840"/>
-            <a:ext cx="6885432" cy="320040"/>
-          </a:xfrm>
-          <a:prstGeom prst="rect">
-            <a:avLst/>
-          </a:prstGeom>
-          <a:noFill/>
-          <a:ln/>
-        </p:spPr>
-        <p:txBody>
-          <a:bodyPr wrap="square" lIns="0" tIns="0" rIns="0" bIns="0" rtlCol="0" anchor="t"/>
-          <a:lstStyle/>
-          <a:p>
-            <a:pPr indent="0" marL="0">
-              <a:buNone/>
-            </a:pPr>
-            <a:r>
-              <a:rPr lang="en-US" sz="1400" dirty="0">
-                <a:solidFill>
-                  <a:schemeClr val="tx1"/>
-                </a:solidFill>
-              </a:rPr>
-              <a:t>A la fecha </a:t>
-            </a:r>
-            <a:pPr indent="0" marL="0">
-              <a:buNone/>
-            </a:pPr>
-            <a:r>
-              <a:rPr lang="en-US" sz="1400" b="1" dirty="0">
-                <a:solidFill>
-                  <a:schemeClr val="tx1"/>
-                </a:solidFill>
-              </a:rPr>
-              <a:t>no se ha recibido el análisis solicitado</a:t>
-            </a:r>
-            <a:pPr indent="0" marL="0">
-              <a:buNone/>
-            </a:pPr>
-            <a:r>
-              <a:rPr lang="en-US" sz="1400" dirty="0">
-                <a:solidFill>
-                  <a:schemeClr val="tx1"/>
-                </a:solidFill>
-              </a:rPr>
-              <a:t>; se mantiene en seguimiento.</a:t>
-            </a:r>
-            <a:endParaRPr lang="en-US" sz="1400" dirty="0"/>
-          </a:p>
-        </p:txBody>
-      </p:sp>
-      <p:sp>
-        <p:nvSpPr>
-          <p:cNvPr id="26" name="Línea de tiempo"/>
-          <p:cNvSpPr/>
-          <p:nvPr/>
-        </p:nvSpPr>
-        <p:spPr>
-          <a:xfrm>
-            <a:off x="4809744" y="5056632"/>
-            <a:ext cx="6227064" cy="0"/>
-          </a:xfrm>
-          <a:prstGeom prst="line">
-            <a:avLst/>
-          </a:prstGeom>
-          <a:noFill/>
-          <a:ln w="25400">
+            <a:ext cx="3374136" cy="1051560"/>
+          </a:xfrm>
+          <a:prstGeom prst="roundRect">
+            <a:avLst>
+              <a:gd name="adj" fmla="val 8696"/>
+            </a:avLst>
+          </a:prstGeom>
+          <a:solidFill>
+            <a:schemeClr val="bg1"/>
+          </a:solidFill>
+          <a:ln w="12700">
             <a:solidFill>
-              <a:srgbClr val="8CC6CF"/>
+              <a:srgbClr val="D5DEE6"/>
             </a:solidFill>
             <a:prstDash val="solid"/>
           </a:ln>
@@ -7674,24 +7620,112 @@
       </p:sp>
       <p:sp>
         <p:nvSpPr>
-          <p:cNvPr id="27" name="Hito 1"/>
+          <p:cNvPr id="26" name="Text 19"/>
+          <p:cNvSpPr txBox="1"/>
+          <p:nvPr/>
+        </p:nvSpPr>
+        <p:spPr>
+          <a:xfrm>
+            <a:off x="4663440" y="4507992"/>
+            <a:ext cx="3017520" cy="384048"/>
+          </a:xfrm>
+          <a:prstGeom prst="rect">
+            <a:avLst/>
+          </a:prstGeom>
+          <a:noFill/>
+          <a:ln/>
+        </p:spPr>
+        <p:txBody>
+          <a:bodyPr wrap="square" lIns="0" tIns="0" rIns="0" bIns="0" rtlCol="0" anchor="t"/>
+          <a:lstStyle/>
+          <a:p>
+            <a:pPr indent="0" marL="0">
+              <a:buNone/>
+            </a:pPr>
+            <a:r>
+              <a:rPr lang="en-US" sz="2200" b="1" dirty="0">
+                <a:solidFill>
+                  <a:schemeClr val="accent1"/>
+                </a:solidFill>
+              </a:rPr>
+              <a:t>$1,073,528.39</a:t>
+            </a:r>
+            <a:endParaRPr lang="en-US" sz="2200" dirty="0"/>
+          </a:p>
+        </p:txBody>
+      </p:sp>
+      <p:sp>
+        <p:nvSpPr>
+          <p:cNvPr id="27" name="Text 20"/>
+          <p:cNvSpPr txBox="1"/>
+          <p:nvPr/>
+        </p:nvSpPr>
+        <p:spPr>
+          <a:xfrm>
+            <a:off x="4663440" y="4892040"/>
+            <a:ext cx="3063240" cy="548640"/>
+          </a:xfrm>
+          <a:prstGeom prst="rect">
+            <a:avLst/>
+          </a:prstGeom>
+          <a:noFill/>
+          <a:ln/>
+        </p:spPr>
+        <p:txBody>
+          <a:bodyPr wrap="square" lIns="0" tIns="0" rIns="0" bIns="0" rtlCol="0" anchor="t"/>
+          <a:lstStyle/>
+          <a:p>
+            <a:pPr indent="0" marL="0">
+              <a:buNone/>
+            </a:pPr>
+            <a:r>
+              <a:rPr lang="en-US" sz="1100" b="1" dirty="0">
+                <a:solidFill>
+                  <a:schemeClr val="tx2"/>
+                </a:solidFill>
+              </a:rPr>
+              <a:t>Liberación de reservas</a:t>
+            </a:r>
+            <a:endParaRPr lang="en-US" sz="1100" dirty="0"/>
+          </a:p>
+          <a:p>
+            <a:pPr indent="0" marL="0">
+              <a:buNone/>
+            </a:pPr>
+            <a:r>
+              <a:rPr lang="en-US" sz="1100" dirty="0">
+                <a:solidFill>
+                  <a:schemeClr val="accent5"/>
+                </a:solidFill>
+              </a:rPr>
+              <a:t>4.33% de los ingresos totales · 100% reversión de estimaciones por incobrabilidad (cta. 1149)</a:t>
+            </a:r>
+            <a:endParaRPr lang="en-US" sz="1100" dirty="0"/>
+          </a:p>
+        </p:txBody>
+      </p:sp>
+      <p:sp>
+        <p:nvSpPr>
+          <p:cNvPr id="28" name="Cifra Recuperación de cartera castigada"/>
           <p:cNvSpPr/>
           <p:nvPr/>
         </p:nvSpPr>
         <p:spPr>
           <a:xfrm>
-            <a:off x="4480560" y="4892040"/>
-            <a:ext cx="329184" cy="329184"/>
-          </a:xfrm>
-          <a:prstGeom prst="ellipse">
-            <a:avLst/>
+            <a:off x="7991856" y="4434840"/>
+            <a:ext cx="3374136" cy="1051560"/>
+          </a:xfrm>
+          <a:prstGeom prst="roundRect">
+            <a:avLst>
+              <a:gd name="adj" fmla="val 8696"/>
+            </a:avLst>
           </a:prstGeom>
           <a:solidFill>
-            <a:schemeClr val="accent1"/>
+            <a:schemeClr val="bg1"/>
           </a:solidFill>
-          <a:ln w="38100">
+          <a:ln w="12700">
             <a:solidFill>
-              <a:srgbClr val="EEF3F7"/>
+              <a:srgbClr val="D5DEE6"/>
             </a:solidFill>
             <a:prstDash val="solid"/>
           </a:ln>
@@ -7699,50 +7733,14 @@
       </p:sp>
       <p:sp>
         <p:nvSpPr>
-          <p:cNvPr id="28" name="Text 21"/>
-          <p:cNvSpPr txBox="1"/>
-          <p:nvPr/>
-        </p:nvSpPr>
-        <p:spPr>
-          <a:xfrm>
-            <a:off x="4480560" y="5303520"/>
-            <a:ext cx="2377440" cy="274320"/>
-          </a:xfrm>
-          <a:prstGeom prst="rect">
-            <a:avLst/>
-          </a:prstGeom>
-          <a:noFill/>
-          <a:ln/>
-        </p:spPr>
-        <p:txBody>
-          <a:bodyPr wrap="square" lIns="0" tIns="0" rIns="0" bIns="0" rtlCol="0" anchor="t"/>
-          <a:lstStyle/>
-          <a:p>
-            <a:pPr algn="l" indent="0" marL="0">
-              <a:buNone/>
-            </a:pPr>
-            <a:r>
-              <a:rPr lang="en-US" sz="1500" b="1" dirty="0">
-                <a:solidFill>
-                  <a:schemeClr val="tx2"/>
-                </a:solidFill>
-              </a:rPr>
-              <a:t>27/08/2026</a:t>
-            </a:r>
-            <a:endParaRPr lang="en-US" sz="1500" dirty="0"/>
-          </a:p>
-        </p:txBody>
-      </p:sp>
-      <p:sp>
-        <p:nvSpPr>
           <p:cNvPr id="29" name="Text 22"/>
           <p:cNvSpPr txBox="1"/>
           <p:nvPr/>
         </p:nvSpPr>
         <p:spPr>
           <a:xfrm>
-            <a:off x="4480560" y="5596128"/>
-            <a:ext cx="2377440" cy="502920"/>
+            <a:off x="8174736" y="4507992"/>
+            <a:ext cx="3017520" cy="384048"/>
           </a:xfrm>
           <a:prstGeom prst="rect">
             <a:avLst/>
@@ -7754,45 +7752,70 @@
           <a:bodyPr wrap="square" lIns="0" tIns="0" rIns="0" bIns="0" rtlCol="0" anchor="t"/>
           <a:lstStyle/>
           <a:p>
-            <a:pPr algn="l" indent="0" marL="0">
-              <a:buNone/>
-            </a:pPr>
-            <a:r>
-              <a:rPr lang="en-US" sz="1200" dirty="0">
+            <a:pPr indent="0" marL="0">
+              <a:buNone/>
+            </a:pPr>
+            <a:r>
+              <a:rPr lang="en-US" sz="2200" b="1" dirty="0">
+                <a:solidFill>
+                  <a:schemeClr val="accent2"/>
+                </a:solidFill>
+              </a:rPr>
+              <a:t>$121,441.73</a:t>
+            </a:r>
+            <a:endParaRPr lang="en-US" sz="2200" dirty="0"/>
+          </a:p>
+        </p:txBody>
+      </p:sp>
+      <p:sp>
+        <p:nvSpPr>
+          <p:cNvPr id="30" name="Text 23"/>
+          <p:cNvSpPr txBox="1"/>
+          <p:nvPr/>
+        </p:nvSpPr>
+        <p:spPr>
+          <a:xfrm>
+            <a:off x="8174736" y="4892040"/>
+            <a:ext cx="3063240" cy="548640"/>
+          </a:xfrm>
+          <a:prstGeom prst="rect">
+            <a:avLst/>
+          </a:prstGeom>
+          <a:noFill/>
+          <a:ln/>
+        </p:spPr>
+        <p:txBody>
+          <a:bodyPr wrap="square" lIns="0" tIns="0" rIns="0" bIns="0" rtlCol="0" anchor="t"/>
+          <a:lstStyle/>
+          <a:p>
+            <a:pPr indent="0" marL="0">
+              <a:buNone/>
+            </a:pPr>
+            <a:r>
+              <a:rPr lang="en-US" sz="1100" b="1" dirty="0">
+                <a:solidFill>
+                  <a:schemeClr val="tx2"/>
+                </a:solidFill>
+              </a:rPr>
+              <a:t>Recuperación de cartera castigada</a:t>
+            </a:r>
+            <a:endParaRPr lang="en-US" sz="1100" dirty="0"/>
+          </a:p>
+          <a:p>
+            <a:pPr indent="0" marL="0">
+              <a:buNone/>
+            </a:pPr>
+            <a:r>
+              <a:rPr lang="en-US" sz="1100" dirty="0">
                 <a:solidFill>
                   <a:schemeClr val="accent5"/>
                 </a:solidFill>
               </a:rPr>
-              <a:t>Acuerdo en Sesión 150</a:t>
-            </a:r>
-            <a:endParaRPr lang="en-US" sz="1200" dirty="0"/>
-          </a:p>
-        </p:txBody>
-      </p:sp>
-      <p:sp>
-        <p:nvSpPr>
-          <p:cNvPr id="30" name="Hito 2"/>
-          <p:cNvSpPr/>
-          <p:nvPr/>
-        </p:nvSpPr>
-        <p:spPr>
-          <a:xfrm>
-            <a:off x="7758684" y="4892040"/>
-            <a:ext cx="329184" cy="329184"/>
-          </a:xfrm>
-          <a:prstGeom prst="ellipse">
-            <a:avLst/>
-          </a:prstGeom>
-          <a:solidFill>
-            <a:schemeClr val="accent1"/>
-          </a:solidFill>
-          <a:ln w="38100">
-            <a:solidFill>
-              <a:srgbClr val="EEF3F7"/>
-            </a:solidFill>
-            <a:prstDash val="solid"/>
-          </a:ln>
-        </p:spPr>
+              <a:t>0.49% de los ingresos totales · 81.06% corresponde a intereses refinanciados</a:t>
+            </a:r>
+            <a:endParaRPr lang="en-US" sz="1100" dirty="0"/>
+          </a:p>
+        </p:txBody>
       </p:sp>
       <p:sp>
         <p:nvSpPr>
@@ -7802,8 +7825,8 @@
         </p:nvSpPr>
         <p:spPr>
           <a:xfrm>
-            <a:off x="6734556" y="5303520"/>
-            <a:ext cx="2377440" cy="274320"/>
+            <a:off x="4480560" y="5577840"/>
+            <a:ext cx="6885432" cy="548640"/>
           </a:xfrm>
           <a:prstGeom prst="rect">
             <a:avLst/>
@@ -7815,151 +7838,29 @@
           <a:bodyPr wrap="square" lIns="0" tIns="0" rIns="0" bIns="0" rtlCol="0" anchor="t"/>
           <a:lstStyle/>
           <a:p>
-            <a:pPr algn="ctr" indent="0" marL="0">
-              <a:buNone/>
-            </a:pPr>
-            <a:r>
-              <a:rPr lang="en-US" sz="1500" b="1" dirty="0">
-                <a:solidFill>
-                  <a:schemeClr val="tx2"/>
-                </a:solidFill>
-              </a:rPr>
-              <a:t>10/09/2026</a:t>
-            </a:r>
-            <a:endParaRPr lang="en-US" sz="1500" dirty="0"/>
-          </a:p>
-        </p:txBody>
-      </p:sp>
-      <p:sp>
-        <p:nvSpPr>
-          <p:cNvPr id="32" name="Text 25"/>
-          <p:cNvSpPr txBox="1"/>
-          <p:nvPr/>
-        </p:nvSpPr>
-        <p:spPr>
-          <a:xfrm>
-            <a:off x="6734556" y="5596128"/>
-            <a:ext cx="2377440" cy="502920"/>
-          </a:xfrm>
-          <a:prstGeom prst="rect">
-            <a:avLst/>
-          </a:prstGeom>
-          <a:noFill/>
-          <a:ln/>
-        </p:spPr>
-        <p:txBody>
-          <a:bodyPr wrap="square" lIns="0" tIns="0" rIns="0" bIns="0" rtlCol="0" anchor="t"/>
-          <a:lstStyle/>
-          <a:p>
-            <a:pPr algn="ctr" indent="0" marL="0">
-              <a:buNone/>
-            </a:pPr>
-            <a:r>
-              <a:rPr lang="en-US" sz="1200" dirty="0">
-                <a:solidFill>
-                  <a:schemeClr val="accent5"/>
-                </a:solidFill>
-              </a:rPr>
-              <a:t>Nota recibida por Gerencia de Finanzas (Paula Calderón)</a:t>
-            </a:r>
-            <a:endParaRPr lang="en-US" sz="1200" dirty="0"/>
-          </a:p>
-        </p:txBody>
-      </p:sp>
-      <p:sp>
-        <p:nvSpPr>
-          <p:cNvPr id="33" name="Hito 3"/>
-          <p:cNvSpPr/>
-          <p:nvPr/>
-        </p:nvSpPr>
-        <p:spPr>
-          <a:xfrm>
-            <a:off x="11036808" y="4892040"/>
-            <a:ext cx="329184" cy="329184"/>
-          </a:xfrm>
-          <a:prstGeom prst="ellipse">
-            <a:avLst/>
-          </a:prstGeom>
-          <a:solidFill>
-            <a:schemeClr val="accent3"/>
-          </a:solidFill>
-          <a:ln w="38100">
-            <a:solidFill>
-              <a:srgbClr val="EEF3F7"/>
-            </a:solidFill>
-            <a:prstDash val="solid"/>
-          </a:ln>
-        </p:spPr>
-      </p:sp>
-      <p:sp>
-        <p:nvSpPr>
-          <p:cNvPr id="34" name="Text 27"/>
-          <p:cNvSpPr txBox="1"/>
-          <p:nvPr/>
-        </p:nvSpPr>
-        <p:spPr>
-          <a:xfrm>
-            <a:off x="8988552" y="5303520"/>
-            <a:ext cx="2377440" cy="274320"/>
-          </a:xfrm>
-          <a:prstGeom prst="rect">
-            <a:avLst/>
-          </a:prstGeom>
-          <a:noFill/>
-          <a:ln/>
-        </p:spPr>
-        <p:txBody>
-          <a:bodyPr wrap="square" lIns="0" tIns="0" rIns="0" bIns="0" rtlCol="0" anchor="t"/>
-          <a:lstStyle/>
-          <a:p>
-            <a:pPr algn="r" indent="0" marL="0">
-              <a:buNone/>
-            </a:pPr>
-            <a:r>
-              <a:rPr lang="en-US" sz="1500" b="1" dirty="0">
-                <a:solidFill>
-                  <a:schemeClr val="accent3"/>
-                </a:solidFill>
-              </a:rPr>
-              <a:t>Pendiente</a:t>
-            </a:r>
-            <a:endParaRPr lang="en-US" sz="1500" dirty="0"/>
-          </a:p>
-        </p:txBody>
-      </p:sp>
-      <p:sp>
-        <p:nvSpPr>
-          <p:cNvPr id="35" name="Text 28"/>
-          <p:cNvSpPr txBox="1"/>
-          <p:nvPr/>
-        </p:nvSpPr>
-        <p:spPr>
-          <a:xfrm>
-            <a:off x="8988552" y="5596128"/>
-            <a:ext cx="2377440" cy="502920"/>
-          </a:xfrm>
-          <a:prstGeom prst="rect">
-            <a:avLst/>
-          </a:prstGeom>
-          <a:noFill/>
-          <a:ln/>
-        </p:spPr>
-        <p:txBody>
-          <a:bodyPr wrap="square" lIns="0" tIns="0" rIns="0" bIns="0" rtlCol="0" anchor="t"/>
-          <a:lstStyle/>
-          <a:p>
-            <a:pPr algn="r" indent="0" marL="0">
-              <a:buNone/>
-            </a:pPr>
-            <a:r>
-              <a:rPr lang="en-US" sz="1200" dirty="0">
-                <a:solidFill>
-                  <a:schemeClr val="accent5"/>
-                </a:solidFill>
-              </a:rPr>
-              <a:t>Presentación del análisis al Comité y Consejo</a:t>
-            </a:r>
-            <a:endParaRPr lang="en-US" sz="1200" dirty="0"/>
+            <a:pPr indent="0" marL="0">
+              <a:buNone/>
+            </a:pPr>
+            <a:r>
+              <a:rPr lang="en-US" sz="1300" b="1" dirty="0">
+                <a:solidFill>
+                  <a:schemeClr val="tx1"/>
+                </a:solidFill>
+              </a:rPr>
+              <a:t>Conclusión: </a:t>
+            </a:r>
+            <a:pPr indent="0" marL="0">
+              <a:buNone/>
+            </a:pPr>
+            <a:r>
+              <a:rPr lang="en-US" sz="1300" dirty="0">
+                <a:solidFill>
+                  <a:schemeClr val="tx1"/>
+                </a:solidFill>
+              </a:rPr>
+              <a:t>mismo ámbito (riesgo crediticio), origen distinto: la liberación revierte provisiones por mejora crediticia; la recuperación son cobros de créditos ya castigados.</a:t>
+            </a:r>
+            <a:endParaRPr lang="en-US" sz="1300" dirty="0"/>
           </a:p>
         </p:txBody>
       </p:sp>
@@ -10728,7 +10629,7 @@
                   <a:schemeClr val="accent6"/>
                 </a:solidFill>
               </a:rPr>
-              <a:t>NOTA 02 · 03</a:t>
+              <a:t>NOTA 03</a:t>
             </a:r>
             <a:endParaRPr lang="en-US" sz="1200" dirty="0"/>
           </a:p>
@@ -10764,7 +10665,7 @@
                   <a:schemeClr val="bg1"/>
                 </a:solidFill>
               </a:rPr>
-              <a:t>Requerir la presentación de los análisis pendientes</a:t>
+              <a:t>Requerir la presentación del análisis de cartera reestructurada</a:t>
             </a:r>
             <a:endParaRPr lang="en-US" sz="2000" dirty="0"/>
           </a:p>
@@ -10800,7 +10701,7 @@
                   <a:schemeClr val="accent6"/>
                 </a:solidFill>
               </a:rPr>
-              <a:t>Gerencia de Finanzas y Planificación · Jefatura de Soluciones Financieras</a:t>
+              <a:t>Jefatura de Soluciones Financieras · nota recibida el 10/09/2026</a:t>
             </a:r>
             <a:endParaRPr lang="en-US" sz="1300" dirty="0"/>
           </a:p>

</xml_diff>

<commit_message>
Add conclusion summaries to the evidence column of the tracking matrix
Co-Authored-By: Claude Opus 5.5 <noreply@anthropic.com>
Claude-Session: https://claude.ai/code/session_012D3KgoL7WmAgwT84y3f3Gg
</commit_message>
<xml_diff>
--- a/seguimiento-comite-riesgos-sesion-150/Seguimiento_Acuerdos_Comite_Riesgo_Sesion_150.pptx
+++ b/seguimiento-comite-riesgos-sesion-150/Seguimiento_Acuerdos_Comite_Riesgo_Sesion_150.pptx
@@ -3961,11 +3961,11 @@
             <a:tbl>
               <a:tblPr/>
               <a:tblGrid>
-                <a:gridCol w="868680"/>
-                <a:gridCol w="2240280"/>
-                <a:gridCol w="3429000"/>
-                <a:gridCol w="3182112"/>
-                <a:gridCol w="1371600"/>
+                <a:gridCol w="777240"/>
+                <a:gridCol w="2103120"/>
+                <a:gridCol w="2788920"/>
+                <a:gridCol w="4160520"/>
+                <a:gridCol w="1261872"/>
               </a:tblGrid>
               <a:tr h="411480">
                 <a:tc>
@@ -4481,14 +4481,39 @@
                         <a:buNone/>
                       </a:pPr>
                       <a:r>
-                        <a:rPr lang="en-US" sz="1200" dirty="0">
+                        <a:rPr lang="en-US" sz="1100" dirty="0">
+                          <a:solidFill>
+                            <a:schemeClr val="accent5"/>
+                          </a:solidFill>
+                        </a:rPr>
+                        <a:t>Informe de visitas del 16/10/2026 · 10 depositantes ($27.15 M)</a:t>
+                      </a:r>
+                      <a:endParaRPr lang="en-US" sz="1100" dirty="0"/>
+                    </a:p>
+                    <a:p>
+                      <a:pPr indent="0" marL="0">
+                        <a:buNone/>
+                      </a:pPr>
+                      <a:r>
+                        <a:rPr lang="en-US" sz="1100" b="1" dirty="0">
+                          <a:solidFill>
+                            <a:schemeClr val="tx2"/>
+                          </a:solidFill>
+                        </a:rPr>
+                        <a:t>Conclusión: </a:t>
+                      </a:r>
+                      <a:pPr indent="0" marL="0">
+                        <a:buNone/>
+                      </a:pPr>
+                      <a:r>
+                        <a:rPr lang="en-US" sz="1100" dirty="0">
                           <a:solidFill>
                             <a:schemeClr val="tx1"/>
                           </a:solidFill>
                         </a:rPr>
-                        <a:t>Informe de visitas del 16/10/2026: 10 depositantes visitados ($27.15 M); 69.40% con beneficiarios afiliados</a:t>
+                        <a:t>69.40% está mitigado con beneficiarios afiliados; el riesgo se concentra en 3 jurídicos (24.20%), sensibles a tasas, y 1 depositante sin beneficiarios afiliados (6.40%).</a:t>
                       </a:r>
-                      <a:endParaRPr lang="en-US" sz="1200" dirty="0"/>
+                      <a:endParaRPr lang="en-US" sz="1100" dirty="0"/>
                     </a:p>
                   </a:txBody>
                   <a:tcPr marL="91440" marR="91440" marT="54864" marB="54864" anchor="ctr">
@@ -4802,14 +4827,39 @@
                         <a:buNone/>
                       </a:pPr>
                       <a:r>
-                        <a:rPr lang="en-US" sz="1200" dirty="0">
+                        <a:rPr lang="en-US" sz="1100" dirty="0">
+                          <a:solidFill>
+                            <a:schemeClr val="accent5"/>
+                          </a:solidFill>
+                        </a:rPr>
+                        <a:t>Memorando 04_2026 del 30/09/2026</a:t>
+                      </a:r>
+                      <a:endParaRPr lang="en-US" sz="1100" dirty="0"/>
+                    </a:p>
+                    <a:p>
+                      <a:pPr indent="0" marL="0">
+                        <a:buNone/>
+                      </a:pPr>
+                      <a:r>
+                        <a:rPr lang="en-US" sz="1100" b="1" dirty="0">
+                          <a:solidFill>
+                            <a:schemeClr val="tx2"/>
+                          </a:solidFill>
+                        </a:rPr>
+                        <a:t>Conclusión: </a:t>
+                      </a:r>
+                      <a:pPr indent="0" marL="0">
+                        <a:buNone/>
+                      </a:pPr>
+                      <a:r>
+                        <a:rPr lang="en-US" sz="1100" dirty="0">
                           <a:solidFill>
                             <a:schemeClr val="tx1"/>
                           </a:solidFill>
                         </a:rPr>
-                        <a:t>Memorando 04_2026 (30/09/2026): liberación $1,073,528.39 (4.33% de ingresos); recuperación castigada $121,441.73 (0.49%)</a:t>
+                        <a:t>liberación de reservas $1,073,528.39 (4.33% de ingresos) por mejora crediticia; recuperación de castigados $121,441.73 (0.49%) por cobros efectivos. Origen contable distinto.</a:t>
                       </a:r>
-                      <a:endParaRPr lang="en-US" sz="1200" dirty="0"/>
+                      <a:endParaRPr lang="en-US" sz="1100" dirty="0"/>
                     </a:p>
                   </a:txBody>
                   <a:tcPr marL="91440" marR="91440" marT="54864" marB="54864" anchor="ctr">
@@ -5123,14 +5173,39 @@
                         <a:buNone/>
                       </a:pPr>
                       <a:r>
-                        <a:rPr lang="en-US" sz="1200" dirty="0">
+                        <a:rPr lang="en-US" sz="1100" dirty="0">
+                          <a:solidFill>
+                            <a:schemeClr val="accent5"/>
+                          </a:solidFill>
+                        </a:rPr>
+                        <a:t>Nota recibida el 10/09/2026</a:t>
+                      </a:r>
+                      <a:endParaRPr lang="en-US" sz="1100" dirty="0"/>
+                    </a:p>
+                    <a:p>
+                      <a:pPr indent="0" marL="0">
+                        <a:buNone/>
+                      </a:pPr>
+                      <a:r>
+                        <a:rPr lang="en-US" sz="1100" b="1" dirty="0">
+                          <a:solidFill>
+                            <a:schemeClr val="tx2"/>
+                          </a:solidFill>
+                        </a:rPr>
+                        <a:t>Conclusión: </a:t>
+                      </a:r>
+                      <a:pPr indent="0" marL="0">
+                        <a:buNone/>
+                      </a:pPr>
+                      <a:r>
+                        <a:rPr lang="en-US" sz="1100" dirty="0">
                           <a:solidFill>
                             <a:schemeClr val="tx1"/>
                           </a:solidFill>
                         </a:rPr>
-                        <a:t>Nota recibida el 10/09/2026. Análisis pendiente de presentación</a:t>
+                        <a:t>análisis aún no presentado; se mantiene en seguimiento para la próxima sesión.</a:t>
                       </a:r>
-                      <a:endParaRPr lang="en-US" sz="1200" dirty="0"/>
+                      <a:endParaRPr lang="en-US" sz="1100" dirty="0"/>
                     </a:p>
                   </a:txBody>
                   <a:tcPr marL="91440" marR="91440" marT="54864" marB="54864" anchor="ctr">
@@ -5444,14 +5519,39 @@
                         <a:buNone/>
                       </a:pPr>
                       <a:r>
-                        <a:rPr lang="en-US" sz="1200" dirty="0">
+                        <a:rPr lang="en-US" sz="1100" dirty="0">
+                          <a:solidFill>
+                            <a:schemeClr val="accent5"/>
+                          </a:solidFill>
+                        </a:rPr>
+                        <a:t>Solicitudes a AFP CONFIA, AFP CRECER, IPSFA e ISP · respuesta 03/10/2026</a:t>
+                      </a:r>
+                      <a:endParaRPr lang="en-US" sz="1100" dirty="0"/>
+                    </a:p>
+                    <a:p>
+                      <a:pPr indent="0" marL="0">
+                        <a:buNone/>
+                      </a:pPr>
+                      <a:r>
+                        <a:rPr lang="en-US" sz="1100" b="1" dirty="0">
+                          <a:solidFill>
+                            <a:schemeClr val="tx2"/>
+                          </a:solidFill>
+                        </a:rPr>
+                        <a:t>Conclusión: </a:t>
+                      </a:r>
+                      <a:pPr indent="0" marL="0">
+                        <a:buNone/>
+                      </a:pPr>
+                      <a:r>
+                        <a:rPr lang="en-US" sz="1100" dirty="0">
                           <a:solidFill>
                             <a:schemeClr val="tx1"/>
                           </a:solidFill>
                         </a:rPr>
-                        <a:t>Solicitudes a AFP CONFIA, AFP CRECER, IPSFA e ISP. Respuesta 03/10/2026: COMEDICA aún no califica como entidad receptora</a:t>
+                        <a:t>las instituciones indicaron que COMEDICA aún no califica como entidad receptora de pensiones.</a:t>
                       </a:r>
-                      <a:endParaRPr lang="en-US" sz="1200" dirty="0"/>
+                      <a:endParaRPr lang="en-US" sz="1100" dirty="0"/>
                     </a:p>
                   </a:txBody>
                   <a:tcPr marL="91440" marR="91440" marT="54864" marB="54864" anchor="ctr">

</xml_diff>

<commit_message>
Mark Nota 03 as completed with restructured portfolio analysis evidence
Co-Authored-By: Claude Opus 5.5 <noreply@anthropic.com>
Claude-Session: https://claude.ai/code/session_012D3KgoL7WmAgwT84y3f3Gg
</commit_message>
<xml_diff>
--- a/seguimiento-comite-riesgos-sesion-150/Seguimiento_Acuerdos_Comite_Riesgo_Sesion_150.pptx
+++ b/seguimiento-comite-riesgos-sesion-150/Seguimiento_Acuerdos_Comite_Riesgo_Sesion_150.pptx
@@ -2592,7 +2592,7 @@
                   <a:schemeClr val="tx2"/>
                 </a:solidFill>
               </a:rPr>
-              <a:t>4 acuerdos en seguimiento: 3 atendidos y 1 en proceso</a:t>
+              <a:t>Los 4 acuerdos de la Sesión 150 fueron atendidos</a:t>
             </a:r>
             <a:endParaRPr lang="en-US" sz="3400" dirty="0"/>
           </a:p>
@@ -2780,7 +2780,7 @@
                   <a:schemeClr val="tx1"/>
                 </a:solidFill>
               </a:rPr>
-              <a:t>Acuerdos atendidos con respuesta</a:t>
+              <a:t>Acuerdos cumplidos con evidencia</a:t>
             </a:r>
             <a:endParaRPr lang="en-US" sz="1500" dirty="0"/>
           </a:p>
@@ -2835,7 +2835,7 @@
             <a:r>
               <a:rPr lang="en-US" sz="6000" b="1" dirty="0">
                 <a:solidFill>
-                  <a:schemeClr val="accent3"/>
+                  <a:schemeClr val="accent4"/>
                 </a:solidFill>
               </a:rPr>
               <a:t>1</a:t>
@@ -2874,7 +2874,7 @@
                   <a:schemeClr val="tx1"/>
                 </a:solidFill>
               </a:rPr>
-              <a:t>Análisis pendiente de presentar</a:t>
+              <a:t>Atendido con resultado no favorable</a:t>
             </a:r>
             <a:endParaRPr lang="en-US" sz="1500" dirty="0"/>
           </a:p>
@@ -3526,7 +3526,7 @@
       </p:sp>
       <p:sp>
         <p:nvSpPr>
-          <p:cNvPr id="33" name="Estado EN PROCESO"/>
+          <p:cNvPr id="33" name="Estado CUMPLIDO"/>
           <p:cNvSpPr txBox="1"/>
           <p:nvPr/>
         </p:nvSpPr>
@@ -3541,7 +3541,7 @@
             </a:avLst>
           </a:prstGeom>
           <a:solidFill>
-            <a:schemeClr val="accent3"/>
+            <a:schemeClr val="accent2"/>
           </a:solidFill>
           <a:ln/>
         </p:spPr>
@@ -3558,7 +3558,7 @@
                   <a:schemeClr val="bg1"/>
                 </a:solidFill>
               </a:rPr>
-              <a:t>EN PROCESO</a:t>
+              <a:t>CUMPLIDO</a:t>
             </a:r>
             <a:endParaRPr lang="en-US" sz="1200" dirty="0"/>
           </a:p>
@@ -5178,7 +5178,7 @@
                             <a:schemeClr val="accent5"/>
                           </a:solidFill>
                         </a:rPr>
-                        <a:t>Nota recibida el 10/09/2026</a:t>
+                        <a:t>Informe de análisis del 25/09/2026 · 554 referencias ($16.42 M)</a:t>
                       </a:r>
                       <a:endParaRPr lang="en-US" sz="1100" dirty="0"/>
                     </a:p>
@@ -5203,7 +5203,7 @@
                             <a:schemeClr val="tx1"/>
                           </a:solidFill>
                         </a:rPr>
-                        <a:t>análisis aún no presentado; se mantiene en seguimiento para la próxima sesión.</a:t>
+                        <a:t>causas: sobreendeudamiento, menor ingreso del hogar y jubilación. Mora &gt;90 días 10.63% y 42.3% fuera de A1; creció 64.87% desde 2019 y ya es un componente estructural.</a:t>
                       </a:r>
                       <a:endParaRPr lang="en-US" sz="1100" dirty="0"/>
                     </a:p>
@@ -5264,7 +5264,7 @@
                             <a:schemeClr val="bg1"/>
                           </a:solidFill>
                         </a:rPr>
-                        <a:t>EN PROCESO</a:t>
+                        <a:t>CUMPLIDO</a:t>
                       </a:r>
                       <a:endParaRPr lang="en-US" sz="1100" dirty="0"/>
                     </a:p>
@@ -5307,7 +5307,7 @@
                       <a:tailEnd type="none" w="med" len="med"/>
                     </a:lnB>
                     <a:solidFill>
-                      <a:schemeClr val="accent3"/>
+                      <a:schemeClr val="accent2"/>
                     </a:solidFill>
                   </a:tcPr>
                 </a:tc>
@@ -8301,7 +8301,7 @@
             </a:avLst>
           </a:prstGeom>
           <a:solidFill>
-            <a:schemeClr val="accent3"/>
+            <a:schemeClr val="accent2"/>
           </a:solidFill>
           <a:ln/>
         </p:spPr>
@@ -8374,7 +8374,7 @@
                   <a:schemeClr val="bg1"/>
                 </a:solidFill>
               </a:rPr>
-              <a:t>EN PROCESO</a:t>
+              <a:t>CUMPLIDO</a:t>
             </a:r>
             <a:endParaRPr lang="en-US" sz="1400" dirty="0"/>
           </a:p>
@@ -8441,7 +8441,7 @@
                   <a:schemeClr val="accent1"/>
                 </a:solidFill>
               </a:rPr>
-              <a:t>NOTA DEL COMITÉ</a:t>
+              <a:t>INFORME DE ANÁLISIS</a:t>
             </a:r>
             <a:endParaRPr lang="en-US" sz="1100" dirty="0"/>
           </a:p>
@@ -8477,7 +8477,7 @@
                   <a:schemeClr val="accent5"/>
                 </a:solidFill>
               </a:rPr>
-              <a:t>10/09/2026 · Recibida en Depto. de Soluciones el 10/09/2026</a:t>
+              <a:t>25/09/2026 · Departamento de Soluciones Financieras</a:t>
             </a:r>
             <a:endParaRPr lang="en-US" sz="1200" dirty="0"/>
           </a:p>
@@ -8782,80 +8782,26 @@
       </p:sp>
       <p:sp>
         <p:nvSpPr>
-          <p:cNvPr id="25" name="Text 18"/>
-          <p:cNvSpPr txBox="1"/>
+          <p:cNvPr id="25" name="Indicador Saldo al 31/08/2026"/>
+          <p:cNvSpPr/>
           <p:nvPr/>
         </p:nvSpPr>
         <p:spPr>
           <a:xfrm>
             <a:off x="4480560" y="4206240"/>
-            <a:ext cx="6885432" cy="320040"/>
-          </a:xfrm>
-          <a:prstGeom prst="rect">
-            <a:avLst/>
-          </a:prstGeom>
-          <a:noFill/>
-          <a:ln/>
-        </p:spPr>
-        <p:txBody>
-          <a:bodyPr wrap="square" lIns="0" tIns="0" rIns="0" bIns="0" rtlCol="0" anchor="t"/>
-          <a:lstStyle/>
-          <a:p>
-            <a:pPr indent="0" marL="0">
-              <a:buNone/>
-            </a:pPr>
-            <a:r>
-              <a:rPr lang="en-US" sz="1400" dirty="0">
-                <a:solidFill>
-                  <a:schemeClr val="tx1"/>
-                </a:solidFill>
-              </a:rPr>
-              <a:t>A la fecha </a:t>
-            </a:r>
-            <a:pPr indent="0" marL="0">
-              <a:buNone/>
-            </a:pPr>
-            <a:r>
-              <a:rPr lang="en-US" sz="1400" b="1" dirty="0">
-                <a:solidFill>
-                  <a:schemeClr val="tx1"/>
-                </a:solidFill>
-              </a:rPr>
-              <a:t>no se ha recibido el análisis solicitado</a:t>
-            </a:r>
-            <a:pPr indent="0" marL="0">
-              <a:buNone/>
-            </a:pPr>
-            <a:r>
-              <a:rPr lang="en-US" sz="1400" dirty="0">
-                <a:solidFill>
-                  <a:schemeClr val="tx1"/>
-                </a:solidFill>
-              </a:rPr>
-              <a:t>; se mantiene en seguimiento.</a:t>
-            </a:r>
-            <a:endParaRPr lang="en-US" sz="1400" dirty="0"/>
-          </a:p>
-        </p:txBody>
-      </p:sp>
-      <p:sp>
-        <p:nvSpPr>
-          <p:cNvPr id="26" name="Línea de tiempo"/>
-          <p:cNvSpPr/>
-          <p:nvPr/>
-        </p:nvSpPr>
-        <p:spPr>
-          <a:xfrm>
-            <a:off x="4809744" y="4828032"/>
-            <a:ext cx="6227064" cy="0"/>
-          </a:xfrm>
-          <a:prstGeom prst="line">
-            <a:avLst/>
-          </a:prstGeom>
-          <a:noFill/>
-          <a:ln w="25400">
+            <a:ext cx="1618488" cy="1005840"/>
+          </a:xfrm>
+          <a:prstGeom prst="roundRect">
+            <a:avLst>
+              <a:gd name="adj" fmla="val 9091"/>
+            </a:avLst>
+          </a:prstGeom>
+          <a:solidFill>
+            <a:schemeClr val="bg1"/>
+          </a:solidFill>
+          <a:ln w="12700">
             <a:solidFill>
-              <a:srgbClr val="8CC6CF"/>
+              <a:srgbClr val="D5DEE6"/>
             </a:solidFill>
             <a:prstDash val="solid"/>
           </a:ln>
@@ -8863,24 +8809,112 @@
       </p:sp>
       <p:sp>
         <p:nvSpPr>
-          <p:cNvPr id="27" name="Hito 1"/>
+          <p:cNvPr id="26" name="Text 19"/>
+          <p:cNvSpPr txBox="1"/>
+          <p:nvPr/>
+        </p:nvSpPr>
+        <p:spPr>
+          <a:xfrm>
+            <a:off x="4617720" y="4279392"/>
+            <a:ext cx="1344168" cy="384048"/>
+          </a:xfrm>
+          <a:prstGeom prst="rect">
+            <a:avLst/>
+          </a:prstGeom>
+          <a:noFill/>
+          <a:ln/>
+        </p:spPr>
+        <p:txBody>
+          <a:bodyPr wrap="square" lIns="0" tIns="0" rIns="0" bIns="0" rtlCol="0" anchor="t"/>
+          <a:lstStyle/>
+          <a:p>
+            <a:pPr indent="0" marL="0">
+              <a:buNone/>
+            </a:pPr>
+            <a:r>
+              <a:rPr lang="en-US" sz="2200" b="1" dirty="0">
+                <a:solidFill>
+                  <a:schemeClr val="tx2"/>
+                </a:solidFill>
+              </a:rPr>
+              <a:t>$16.42 M</a:t>
+            </a:r>
+            <a:endParaRPr lang="en-US" sz="2200" dirty="0"/>
+          </a:p>
+        </p:txBody>
+      </p:sp>
+      <p:sp>
+        <p:nvSpPr>
+          <p:cNvPr id="27" name="Text 20"/>
+          <p:cNvSpPr txBox="1"/>
+          <p:nvPr/>
+        </p:nvSpPr>
+        <p:spPr>
+          <a:xfrm>
+            <a:off x="4617720" y="4681728"/>
+            <a:ext cx="1344168" cy="457200"/>
+          </a:xfrm>
+          <a:prstGeom prst="rect">
+            <a:avLst/>
+          </a:prstGeom>
+          <a:noFill/>
+          <a:ln/>
+        </p:spPr>
+        <p:txBody>
+          <a:bodyPr wrap="square" lIns="0" tIns="0" rIns="0" bIns="0" rtlCol="0" anchor="t"/>
+          <a:lstStyle/>
+          <a:p>
+            <a:pPr indent="0" marL="0">
+              <a:buNone/>
+            </a:pPr>
+            <a:r>
+              <a:rPr lang="en-US" sz="1100" b="1" dirty="0">
+                <a:solidFill>
+                  <a:schemeClr val="tx2"/>
+                </a:solidFill>
+              </a:rPr>
+              <a:t>Saldo al 31/08/2026</a:t>
+            </a:r>
+            <a:endParaRPr lang="en-US" sz="1100" dirty="0"/>
+          </a:p>
+          <a:p>
+            <a:pPr indent="0" marL="0">
+              <a:buNone/>
+            </a:pPr>
+            <a:r>
+              <a:rPr lang="en-US" sz="1100" dirty="0">
+                <a:solidFill>
+                  <a:schemeClr val="accent5"/>
+                </a:solidFill>
+              </a:rPr>
+              <a:t>554 ref. · 473 deudores</a:t>
+            </a:r>
+            <a:endParaRPr lang="en-US" sz="1100" dirty="0"/>
+          </a:p>
+        </p:txBody>
+      </p:sp>
+      <p:sp>
+        <p:nvSpPr>
+          <p:cNvPr id="28" name="Indicador Índice de vencimiento"/>
           <p:cNvSpPr/>
           <p:nvPr/>
         </p:nvSpPr>
         <p:spPr>
           <a:xfrm>
-            <a:off x="4480560" y="4663440"/>
-            <a:ext cx="329184" cy="329184"/>
-          </a:xfrm>
-          <a:prstGeom prst="ellipse">
-            <a:avLst/>
+            <a:off x="6236208" y="4206240"/>
+            <a:ext cx="1618488" cy="1005840"/>
+          </a:xfrm>
+          <a:prstGeom prst="roundRect">
+            <a:avLst>
+              <a:gd name="adj" fmla="val 9091"/>
+            </a:avLst>
           </a:prstGeom>
           <a:solidFill>
-            <a:schemeClr val="accent1"/>
+            <a:schemeClr val="bg1"/>
           </a:solidFill>
-          <a:ln w="38100">
+          <a:ln w="12700">
             <a:solidFill>
-              <a:srgbClr val="EEF3F7"/>
+              <a:srgbClr val="D5DEE6"/>
             </a:solidFill>
             <a:prstDash val="solid"/>
           </a:ln>
@@ -8888,50 +8922,14 @@
       </p:sp>
       <p:sp>
         <p:nvSpPr>
-          <p:cNvPr id="28" name="Text 21"/>
-          <p:cNvSpPr txBox="1"/>
-          <p:nvPr/>
-        </p:nvSpPr>
-        <p:spPr>
-          <a:xfrm>
-            <a:off x="4480560" y="5074920"/>
-            <a:ext cx="2377440" cy="274320"/>
-          </a:xfrm>
-          <a:prstGeom prst="rect">
-            <a:avLst/>
-          </a:prstGeom>
-          <a:noFill/>
-          <a:ln/>
-        </p:spPr>
-        <p:txBody>
-          <a:bodyPr wrap="square" lIns="0" tIns="0" rIns="0" bIns="0" rtlCol="0" anchor="t"/>
-          <a:lstStyle/>
-          <a:p>
-            <a:pPr algn="l" indent="0" marL="0">
-              <a:buNone/>
-            </a:pPr>
-            <a:r>
-              <a:rPr lang="en-US" sz="1500" b="1" dirty="0">
-                <a:solidFill>
-                  <a:schemeClr val="tx2"/>
-                </a:solidFill>
-              </a:rPr>
-              <a:t>27/08/2026</a:t>
-            </a:r>
-            <a:endParaRPr lang="en-US" sz="1500" dirty="0"/>
-          </a:p>
-        </p:txBody>
-      </p:sp>
-      <p:sp>
-        <p:nvSpPr>
           <p:cNvPr id="29" name="Text 22"/>
           <p:cNvSpPr txBox="1"/>
           <p:nvPr/>
         </p:nvSpPr>
         <p:spPr>
           <a:xfrm>
-            <a:off x="4480560" y="5367528"/>
-            <a:ext cx="2377440" cy="502920"/>
+            <a:off x="6373368" y="4279392"/>
+            <a:ext cx="1344168" cy="384048"/>
           </a:xfrm>
           <a:prstGeom prst="rect">
             <a:avLst/>
@@ -8943,41 +8941,93 @@
           <a:bodyPr wrap="square" lIns="0" tIns="0" rIns="0" bIns="0" rtlCol="0" anchor="t"/>
           <a:lstStyle/>
           <a:p>
-            <a:pPr algn="l" indent="0" marL="0">
-              <a:buNone/>
-            </a:pPr>
-            <a:r>
-              <a:rPr lang="en-US" sz="1200" dirty="0">
+            <a:pPr indent="0" marL="0">
+              <a:buNone/>
+            </a:pPr>
+            <a:r>
+              <a:rPr lang="en-US" sz="2200" b="1" dirty="0">
+                <a:solidFill>
+                  <a:schemeClr val="accent4"/>
+                </a:solidFill>
+              </a:rPr>
+              <a:t>10.63%</a:t>
+            </a:r>
+            <a:endParaRPr lang="en-US" sz="2200" dirty="0"/>
+          </a:p>
+        </p:txBody>
+      </p:sp>
+      <p:sp>
+        <p:nvSpPr>
+          <p:cNvPr id="30" name="Text 23"/>
+          <p:cNvSpPr txBox="1"/>
+          <p:nvPr/>
+        </p:nvSpPr>
+        <p:spPr>
+          <a:xfrm>
+            <a:off x="6373368" y="4681728"/>
+            <a:ext cx="1344168" cy="457200"/>
+          </a:xfrm>
+          <a:prstGeom prst="rect">
+            <a:avLst/>
+          </a:prstGeom>
+          <a:noFill/>
+          <a:ln/>
+        </p:spPr>
+        <p:txBody>
+          <a:bodyPr wrap="square" lIns="0" tIns="0" rIns="0" bIns="0" rtlCol="0" anchor="t"/>
+          <a:lstStyle/>
+          <a:p>
+            <a:pPr indent="0" marL="0">
+              <a:buNone/>
+            </a:pPr>
+            <a:r>
+              <a:rPr lang="en-US" sz="1100" b="1" dirty="0">
+                <a:solidFill>
+                  <a:schemeClr val="tx2"/>
+                </a:solidFill>
+              </a:rPr>
+              <a:t>Índice de vencimiento</a:t>
+            </a:r>
+            <a:endParaRPr lang="en-US" sz="1100" dirty="0"/>
+          </a:p>
+          <a:p>
+            <a:pPr indent="0" marL="0">
+              <a:buNone/>
+            </a:pPr>
+            <a:r>
+              <a:rPr lang="en-US" sz="1100" dirty="0">
                 <a:solidFill>
                   <a:schemeClr val="accent5"/>
                 </a:solidFill>
               </a:rPr>
-              <a:t>Acuerdo en Sesión 150</a:t>
-            </a:r>
-            <a:endParaRPr lang="en-US" sz="1200" dirty="0"/>
-          </a:p>
-        </p:txBody>
-      </p:sp>
-      <p:sp>
-        <p:nvSpPr>
-          <p:cNvPr id="30" name="Hito 2"/>
+              <a:t>mora &gt; 90 días</a:t>
+            </a:r>
+            <a:endParaRPr lang="en-US" sz="1100" dirty="0"/>
+          </a:p>
+        </p:txBody>
+      </p:sp>
+      <p:sp>
+        <p:nvSpPr>
+          <p:cNvPr id="31" name="Indicador Saldo en riesgo"/>
           <p:cNvSpPr/>
           <p:nvPr/>
         </p:nvSpPr>
         <p:spPr>
           <a:xfrm>
-            <a:off x="7758684" y="4663440"/>
-            <a:ext cx="329184" cy="329184"/>
-          </a:xfrm>
-          <a:prstGeom prst="ellipse">
-            <a:avLst/>
+            <a:off x="7991856" y="4206240"/>
+            <a:ext cx="1618488" cy="1005840"/>
+          </a:xfrm>
+          <a:prstGeom prst="roundRect">
+            <a:avLst>
+              <a:gd name="adj" fmla="val 9091"/>
+            </a:avLst>
           </a:prstGeom>
           <a:solidFill>
-            <a:schemeClr val="accent1"/>
+            <a:schemeClr val="bg1"/>
           </a:solidFill>
-          <a:ln w="38100">
+          <a:ln w="12700">
             <a:solidFill>
-              <a:srgbClr val="EEF3F7"/>
+              <a:srgbClr val="D5DEE6"/>
             </a:solidFill>
             <a:prstDash val="solid"/>
           </a:ln>
@@ -8985,50 +9035,14 @@
       </p:sp>
       <p:sp>
         <p:nvSpPr>
-          <p:cNvPr id="31" name="Text 24"/>
-          <p:cNvSpPr txBox="1"/>
-          <p:nvPr/>
-        </p:nvSpPr>
-        <p:spPr>
-          <a:xfrm>
-            <a:off x="6734556" y="5074920"/>
-            <a:ext cx="2377440" cy="274320"/>
-          </a:xfrm>
-          <a:prstGeom prst="rect">
-            <a:avLst/>
-          </a:prstGeom>
-          <a:noFill/>
-          <a:ln/>
-        </p:spPr>
-        <p:txBody>
-          <a:bodyPr wrap="square" lIns="0" tIns="0" rIns="0" bIns="0" rtlCol="0" anchor="t"/>
-          <a:lstStyle/>
-          <a:p>
-            <a:pPr algn="ctr" indent="0" marL="0">
-              <a:buNone/>
-            </a:pPr>
-            <a:r>
-              <a:rPr lang="en-US" sz="1500" b="1" dirty="0">
-                <a:solidFill>
-                  <a:schemeClr val="tx2"/>
-                </a:solidFill>
-              </a:rPr>
-              <a:t>10/09/2026</a:t>
-            </a:r>
-            <a:endParaRPr lang="en-US" sz="1500" dirty="0"/>
-          </a:p>
-        </p:txBody>
-      </p:sp>
-      <p:sp>
-        <p:nvSpPr>
           <p:cNvPr id="32" name="Text 25"/>
           <p:cNvSpPr txBox="1"/>
           <p:nvPr/>
         </p:nvSpPr>
         <p:spPr>
           <a:xfrm>
-            <a:off x="6734556" y="5367528"/>
-            <a:ext cx="2377440" cy="502920"/>
+            <a:off x="8129016" y="4279392"/>
+            <a:ext cx="1344168" cy="384048"/>
           </a:xfrm>
           <a:prstGeom prst="rect">
             <a:avLst/>
@@ -9040,41 +9054,93 @@
           <a:bodyPr wrap="square" lIns="0" tIns="0" rIns="0" bIns="0" rtlCol="0" anchor="t"/>
           <a:lstStyle/>
           <a:p>
-            <a:pPr algn="ctr" indent="0" marL="0">
-              <a:buNone/>
-            </a:pPr>
-            <a:r>
-              <a:rPr lang="en-US" sz="1200" dirty="0">
+            <a:pPr indent="0" marL="0">
+              <a:buNone/>
+            </a:pPr>
+            <a:r>
+              <a:rPr lang="en-US" sz="2200" b="1" dirty="0">
+                <a:solidFill>
+                  <a:schemeClr val="accent3"/>
+                </a:solidFill>
+              </a:rPr>
+              <a:t>42.3%</a:t>
+            </a:r>
+            <a:endParaRPr lang="en-US" sz="2200" dirty="0"/>
+          </a:p>
+        </p:txBody>
+      </p:sp>
+      <p:sp>
+        <p:nvSpPr>
+          <p:cNvPr id="33" name="Text 26"/>
+          <p:cNvSpPr txBox="1"/>
+          <p:nvPr/>
+        </p:nvSpPr>
+        <p:spPr>
+          <a:xfrm>
+            <a:off x="8129016" y="4681728"/>
+            <a:ext cx="1344168" cy="457200"/>
+          </a:xfrm>
+          <a:prstGeom prst="rect">
+            <a:avLst/>
+          </a:prstGeom>
+          <a:noFill/>
+          <a:ln/>
+        </p:spPr>
+        <p:txBody>
+          <a:bodyPr wrap="square" lIns="0" tIns="0" rIns="0" bIns="0" rtlCol="0" anchor="t"/>
+          <a:lstStyle/>
+          <a:p>
+            <a:pPr indent="0" marL="0">
+              <a:buNone/>
+            </a:pPr>
+            <a:r>
+              <a:rPr lang="en-US" sz="1100" b="1" dirty="0">
+                <a:solidFill>
+                  <a:schemeClr val="tx2"/>
+                </a:solidFill>
+              </a:rPr>
+              <a:t>Saldo en riesgo</a:t>
+            </a:r>
+            <a:endParaRPr lang="en-US" sz="1100" dirty="0"/>
+          </a:p>
+          <a:p>
+            <a:pPr indent="0" marL="0">
+              <a:buNone/>
+            </a:pPr>
+            <a:r>
+              <a:rPr lang="en-US" sz="1100" dirty="0">
                 <a:solidFill>
                   <a:schemeClr val="accent5"/>
                 </a:solidFill>
               </a:rPr>
-              <a:t>Nota recibida por Depto. de Soluciones (Griselda Sigüenza)</a:t>
-            </a:r>
-            <a:endParaRPr lang="en-US" sz="1200" dirty="0"/>
-          </a:p>
-        </p:txBody>
-      </p:sp>
-      <p:sp>
-        <p:nvSpPr>
-          <p:cNvPr id="33" name="Hito 3"/>
+              <a:t>fuera de A1</a:t>
+            </a:r>
+            <a:endParaRPr lang="en-US" sz="1100" dirty="0"/>
+          </a:p>
+        </p:txBody>
+      </p:sp>
+      <p:sp>
+        <p:nvSpPr>
+          <p:cNvPr id="34" name="Indicador Crecimiento"/>
           <p:cNvSpPr/>
           <p:nvPr/>
         </p:nvSpPr>
         <p:spPr>
           <a:xfrm>
-            <a:off x="11036808" y="4663440"/>
-            <a:ext cx="329184" cy="329184"/>
-          </a:xfrm>
-          <a:prstGeom prst="ellipse">
-            <a:avLst/>
+            <a:off x="9747504" y="4206240"/>
+            <a:ext cx="1618488" cy="1005840"/>
+          </a:xfrm>
+          <a:prstGeom prst="roundRect">
+            <a:avLst>
+              <a:gd name="adj" fmla="val 9091"/>
+            </a:avLst>
           </a:prstGeom>
           <a:solidFill>
-            <a:schemeClr val="accent3"/>
+            <a:schemeClr val="bg1"/>
           </a:solidFill>
-          <a:ln w="38100">
+          <a:ln w="12700">
             <a:solidFill>
-              <a:srgbClr val="EEF3F7"/>
+              <a:srgbClr val="D5DEE6"/>
             </a:solidFill>
             <a:prstDash val="solid"/>
           </a:ln>
@@ -9082,50 +9148,14 @@
       </p:sp>
       <p:sp>
         <p:nvSpPr>
-          <p:cNvPr id="34" name="Text 27"/>
-          <p:cNvSpPr txBox="1"/>
-          <p:nvPr/>
-        </p:nvSpPr>
-        <p:spPr>
-          <a:xfrm>
-            <a:off x="8988552" y="5074920"/>
-            <a:ext cx="2377440" cy="274320"/>
-          </a:xfrm>
-          <a:prstGeom prst="rect">
-            <a:avLst/>
-          </a:prstGeom>
-          <a:noFill/>
-          <a:ln/>
-        </p:spPr>
-        <p:txBody>
-          <a:bodyPr wrap="square" lIns="0" tIns="0" rIns="0" bIns="0" rtlCol="0" anchor="t"/>
-          <a:lstStyle/>
-          <a:p>
-            <a:pPr algn="r" indent="0" marL="0">
-              <a:buNone/>
-            </a:pPr>
-            <a:r>
-              <a:rPr lang="en-US" sz="1500" b="1" dirty="0">
-                <a:solidFill>
-                  <a:schemeClr val="accent3"/>
-                </a:solidFill>
-              </a:rPr>
-              <a:t>Pendiente</a:t>
-            </a:r>
-            <a:endParaRPr lang="en-US" sz="1500" dirty="0"/>
-          </a:p>
-        </p:txBody>
-      </p:sp>
-      <p:sp>
-        <p:nvSpPr>
           <p:cNvPr id="35" name="Text 28"/>
           <p:cNvSpPr txBox="1"/>
           <p:nvPr/>
         </p:nvSpPr>
         <p:spPr>
           <a:xfrm>
-            <a:off x="8988552" y="5367528"/>
-            <a:ext cx="2377440" cy="502920"/>
+            <a:off x="9884664" y="4279392"/>
+            <a:ext cx="1344168" cy="384048"/>
           </a:xfrm>
           <a:prstGeom prst="rect">
             <a:avLst/>
@@ -9137,18 +9167,140 @@
           <a:bodyPr wrap="square" lIns="0" tIns="0" rIns="0" bIns="0" rtlCol="0" anchor="t"/>
           <a:lstStyle/>
           <a:p>
-            <a:pPr algn="r" indent="0" marL="0">
-              <a:buNone/>
-            </a:pPr>
-            <a:r>
-              <a:rPr lang="en-US" sz="1200" dirty="0">
+            <a:pPr indent="0" marL="0">
+              <a:buNone/>
+            </a:pPr>
+            <a:r>
+              <a:rPr lang="en-US" sz="2200" b="1" dirty="0">
+                <a:solidFill>
+                  <a:schemeClr val="accent1"/>
+                </a:solidFill>
+              </a:rPr>
+              <a:t>+64.87%</a:t>
+            </a:r>
+            <a:endParaRPr lang="en-US" sz="2200" dirty="0"/>
+          </a:p>
+        </p:txBody>
+      </p:sp>
+      <p:sp>
+        <p:nvSpPr>
+          <p:cNvPr id="36" name="Text 29"/>
+          <p:cNvSpPr txBox="1"/>
+          <p:nvPr/>
+        </p:nvSpPr>
+        <p:spPr>
+          <a:xfrm>
+            <a:off x="9884664" y="4681728"/>
+            <a:ext cx="1344168" cy="457200"/>
+          </a:xfrm>
+          <a:prstGeom prst="rect">
+            <a:avLst/>
+          </a:prstGeom>
+          <a:noFill/>
+          <a:ln/>
+        </p:spPr>
+        <p:txBody>
+          <a:bodyPr wrap="square" lIns="0" tIns="0" rIns="0" bIns="0" rtlCol="0" anchor="t"/>
+          <a:lstStyle/>
+          <a:p>
+            <a:pPr indent="0" marL="0">
+              <a:buNone/>
+            </a:pPr>
+            <a:r>
+              <a:rPr lang="en-US" sz="1100" b="1" dirty="0">
+                <a:solidFill>
+                  <a:schemeClr val="tx2"/>
+                </a:solidFill>
+              </a:rPr>
+              <a:t>Crecimiento</a:t>
+            </a:r>
+            <a:endParaRPr lang="en-US" sz="1100" dirty="0"/>
+          </a:p>
+          <a:p>
+            <a:pPr indent="0" marL="0">
+              <a:buNone/>
+            </a:pPr>
+            <a:r>
+              <a:rPr lang="en-US" sz="1100" dirty="0">
                 <a:solidFill>
                   <a:schemeClr val="accent5"/>
                 </a:solidFill>
               </a:rPr>
-              <a:t>Presentación del análisis al Comité de Riesgos</a:t>
-            </a:r>
-            <a:endParaRPr lang="en-US" sz="1200" dirty="0"/>
+              <a:t>dic-2019 a jul-2026</a:t>
+            </a:r>
+            <a:endParaRPr lang="en-US" sz="1100" dirty="0"/>
+          </a:p>
+        </p:txBody>
+      </p:sp>
+      <p:sp>
+        <p:nvSpPr>
+          <p:cNvPr id="37" name="Text 30"/>
+          <p:cNvSpPr txBox="1"/>
+          <p:nvPr/>
+        </p:nvSpPr>
+        <p:spPr>
+          <a:xfrm>
+            <a:off x="4480560" y="5321808"/>
+            <a:ext cx="6885432" cy="777240"/>
+          </a:xfrm>
+          <a:prstGeom prst="rect">
+            <a:avLst/>
+          </a:prstGeom>
+          <a:noFill/>
+          <a:ln/>
+        </p:spPr>
+        <p:txBody>
+          <a:bodyPr wrap="square" lIns="0" tIns="0" rIns="0" bIns="0" rtlCol="0" anchor="t"/>
+          <a:lstStyle/>
+          <a:p>
+            <a:pPr indent="0" marL="0">
+              <a:buNone/>
+            </a:pPr>
+            <a:r>
+              <a:rPr lang="en-US" sz="1300" b="1" dirty="0">
+                <a:solidFill>
+                  <a:schemeClr val="tx1"/>
+                </a:solidFill>
+              </a:rPr>
+              <a:t>Causas: </a:t>
+            </a:r>
+            <a:pPr indent="0" marL="0">
+              <a:buNone/>
+            </a:pPr>
+            <a:r>
+              <a:rPr lang="en-US" sz="1300" dirty="0">
+                <a:solidFill>
+                  <a:schemeClr val="tx1"/>
+                </a:solidFill>
+              </a:rPr>
+              <a:t>sobreendeudamiento, reducción de ingresos del titular o del hogar y jubilación.</a:t>
+            </a:r>
+            <a:endParaRPr lang="en-US" sz="1300" dirty="0"/>
+          </a:p>
+          <a:p>
+            <a:pPr indent="0" marL="0">
+              <a:buNone/>
+            </a:pPr>
+            <a:r>
+              <a:rPr lang="en-US" sz="1300" b="1" dirty="0">
+                <a:solidFill>
+                  <a:schemeClr val="tx1"/>
+                </a:solidFill>
+              </a:rPr>
+              <a:t>Conclusión: </a:t>
+            </a:r>
+            <a:pPr indent="0" marL="0">
+              <a:buNone/>
+            </a:pPr>
+            <a:r>
+              <a:rPr lang="en-US" sz="1300" dirty="0">
+                <a:solidFill>
+                  <a:schemeClr val="tx1"/>
+                </a:solidFill>
+              </a:rPr>
+              <a:t>pasó de medida coyuntural (COVID-19) a componente estructural; 71 operaciones en categoría E (8.61%) están en recuperación judicial.</a:t>
+            </a:r>
+            <a:endParaRPr lang="en-US" sz="1300" dirty="0"/>
           </a:p>
         </p:txBody>
       </p:sp>
@@ -10627,7 +10779,7 @@
                   <a:schemeClr val="bg1"/>
                 </a:solidFill>
               </a:rPr>
-              <a:t>Acciones para cerrar los acuerdos de la Sesión 150</a:t>
+              <a:t>Acciones derivadas de los acuerdos de la Sesión 150</a:t>
             </a:r>
             <a:endParaRPr lang="en-US" sz="3600" dirty="0"/>
           </a:p>
@@ -10670,7 +10822,7 @@
             <a:avLst/>
           </a:prstGeom>
           <a:solidFill>
-            <a:schemeClr val="accent3"/>
+            <a:schemeClr val="accent1"/>
           </a:solidFill>
           <a:ln/>
         </p:spPr>
@@ -10765,7 +10917,7 @@
                   <a:schemeClr val="bg1"/>
                 </a:solidFill>
               </a:rPr>
-              <a:t>Requerir la presentación del análisis de cartera reestructurada</a:t>
+              <a:t>Reforzar la evaluación de capacidad de pago en el otorgamiento</a:t>
             </a:r>
             <a:endParaRPr lang="en-US" sz="2000" dirty="0"/>
           </a:p>
@@ -10801,7 +10953,7 @@
                   <a:schemeClr val="accent6"/>
                 </a:solidFill>
               </a:rPr>
-              <a:t>Jefatura de Soluciones Financieras · nota recibida el 10/09/2026</a:t>
+              <a:t>Plazo, edad y proximidad al retiro, estabilidad de ingresos y endeudamiento existente</a:t>
             </a:r>
             <a:endParaRPr lang="en-US" sz="1300" dirty="0"/>
           </a:p>

</xml_diff>